<commit_message>
Add speaker scripts (notes in PPTX + Sprechskripte.md)
Co-Authored-By: Claude Sonnet 5.5 <noreply@anthropic.com>
Claude-Session: https://claude.ai/code/session_01Lz9seneFfzqAgdh6m3qyv8
</commit_message>
<xml_diff>
--- a/outputs/Wirtschaftsordnungen_im_Vergleich_neues_Design.pptx
+++ b/outputs/Wirtschaftsordnungen_im_Vergleich_neues_Design.pptx
@@ -129,7 +129,7 @@
   <p:extLst>
     <p:ext uri="{521415D9-36F7-43E2-AB2F-B90AF26B5E84}">
       <p14:sectionLst xmlns:p14="http://schemas.microsoft.com/office/powerpoint/2010/main">
-        <p14:section name="Präsentation" id="{42096f9d-6dbc-b5e5-5a1d-90c34fe40759}">
+        <p14:section name="Präsentation" id="{c9d9b2e7-e32e-0de2-16fa-32323a09e4b3}">
           <p14:sldIdLst>
             <p14:sldId id="256"/>
             <p14:sldId id="257"/>
@@ -560,7 +560,8 @@
           <a:p>
             <a:r>
               <a:rPr lang="en-US" dirty="0"/>
-              <a:t/>
+              <a:t>Sprecher: Anastasiia
+Guten Morgen zusammen. Wir sind Anastasiia, Charlene, Melanie und Yasin, und heute geht es um die Frage: Wie viel Markt – wie viel Staat? Dahinter steckt das Thema Wirtschaftsordnungen. Wir vergleichen vier Länder: Deutschland, Marokko, die Ukraine und Kuba. Ihr seht unten den Messbalken von Markt bis Staat – den werdet ihr in der ganzen Präsentation wiederfinden, und die vier Punkte zeigen, wo wir die Länder grob einordnen.</a:t>
             </a:r>
             <a:endParaRPr lang="en-US" dirty="0"/>
           </a:p>
@@ -648,7 +649,8 @@
           <a:p>
             <a:r>
               <a:rPr lang="en-US" dirty="0"/>
-              <a:t/>
+              <a:t>Sprecher: Melanie
+Jetzt schauen wir auf die vier Länder. Wir stellen allen dieselben sechs Fragen, aber die Länder haben eine unterschiedliche Geschichte, andere Institutionen und aktuelle Herausforderungen. Die Fragen: Eigentum – wem gehören Unternehmen und Produktionsmittel? Entscheidungen – wer entscheidet über Produktion und Investitionen? Preisbildung – am Markt oder staatlich beeinflusst? Wettbewerb – wie frei konkurrieren Unternehmen? Rolle des Staates – setzt er hauptsächlich Regeln oder steuert er unmittelbar? Und soziale Sicherung – wie werden soziale Risiken abgesichert?</a:t>
             </a:r>
             <a:endParaRPr lang="en-US" dirty="0"/>
           </a:p>
@@ -736,7 +738,8 @@
           <a:p>
             <a:r>
               <a:rPr lang="en-US" dirty="0"/>
-              <a:t/>
+              <a:t>Sprecher: Yasin
+Deutschland ist eine Soziale Marktwirtschaft. Private Unternehmen und freie Preisbildung prägen den Alltag, der Staat setzt Wettbewerbs-, Arbeits- und Sozialregeln. Tarifautonomie und soziale Sicherung sind wichtige Bausteine. Seit 1949 prägt dieses Modell die Bundesrepublik. Wettbewerb wird staatlich geschützt, zum Beispiel durch Kartellverbot, Missbrauchsaufsicht und Fusionskontrolle. Bei der Tarifautonomie handeln Gewerkschaften und Arbeitgeber Löhne und Arbeitsbedingungen grundsätzlich selbst aus. Die Besonderheit: die Verbindung von Markt und Sozialstaat.</a:t>
             </a:r>
             <a:endParaRPr lang="en-US" dirty="0"/>
           </a:p>
@@ -824,7 +827,8 @@
           <a:p>
             <a:r>
               <a:rPr lang="en-US" dirty="0"/>
-              <a:t/>
+              <a:t>Sprecher: Yasin
+Marokko ist eine Marktwirtschaft mit starker Staatsrolle. Private Unternehmen und Märkte sind zentral, zugleich prägt der Staat strategische Bereiche, Infrastruktur und Förderung. Informelle Arbeit bleibt für viele Menschen wirtschaftlich bedeutsam – 69,4 Prozent der Beschäftigung waren 2024 informell. Dazu kommen starke öffentliche Investitionen, besonders in Infrastruktur, und Reformen, die Wettbewerb und private Investitionen stärken sollen. Die Besonderheit: ein großer informeller Sektor neben einer modernen Privatwirtschaft.</a:t>
             </a:r>
             <a:endParaRPr lang="en-US" dirty="0"/>
           </a:p>
@@ -912,7 +916,8 @@
           <a:p>
             <a:r>
               <a:rPr lang="en-US" dirty="0"/>
-              <a:t/>
+              <a:t>Sprecher: Yasin
+Die Ukraine ist heute marktwirtschaftlich geprägt, private Unternehmen und Wettbewerb spielen eine wichtige Rolle. Gleichzeitig führen Krieg und Wiederaufbau zu starken staatlichen Eingriffen, während sich das Land wirtschaftlich weiter an die EU annähert. Zur Geschichte: Bis 1991 Planwirtschaft in der Sowjetunion, von 1991 bis 2013 Übergang mit Privatisierung und neuen Märkten, seit 2014 Reformen und eine stärkere EU-Orientierung, seit 2022 Kriegswirtschaft, Wiederaufbau und große Staatsaufgaben. Die heutige Ordnung ist ohne diese historischen Brüche nicht zu verstehen.</a:t>
             </a:r>
             <a:endParaRPr lang="en-US" dirty="0"/>
           </a:p>
@@ -1000,7 +1005,8 @@
           <a:p>
             <a:r>
               <a:rPr lang="en-US" dirty="0"/>
-              <a:t/>
+              <a:t>Sprecher: Charlene
+Kuba ist eine staatsdominierte Planwirtschaft mit zunehmenden Marktöffnungen. Der Staat kontrolliert weiterhin wichtige Wirtschaftsbereiche. Seit den Reformen 2026 erhalten private Unternehmen aber deutlich mehr Spielraum: größere Betriebe, private Banken und private Investitionen sollen möglich werden. Trotzdem bleibt der Staat ein zentraler wirtschaftlicher Akteur. Über 175 Reformmaßnahmen gibt es seit Juni 2026, private Unternehmen mit mehr als 100 Beschäftigten sind möglich, und fast 200 Privatunternehmen haben eine Genehmigung für den Treibstoffhandel. Die Besonderheit: staatliche Dominanz trotz zunehmender Marktöffnung.</a:t>
             </a:r>
             <a:endParaRPr lang="en-US" dirty="0"/>
           </a:p>
@@ -1088,7 +1094,8 @@
           <a:p>
             <a:r>
               <a:rPr lang="en-US" dirty="0"/>
-              <a:t/>
+              <a:t>Sprecher: Charlene
+Jetzt der direkte Vergleich, in drei Teilen. Erste Frage, Eigentum: In Deutschland überwiegend privat, daneben staatliche Unternehmen wie bei der Infrastruktur. In Marokko ebenfalls überwiegend privat, aber viele strategische Bereiche wie Energie sind in staatlicher Hand. In der Ukraine seit 1991 Privatisierung, der Staat behält wichtige strategische Unternehmen. In Kuba überwiegend staatlich, private Unternehmen nur in geringem Umfang. Zweite Frage, Entscheidungen: Deutschland und Marokko entscheiden Unternehmen weitgehend selbst, in Marokko lenkt der Staat in strategischen Bereichen. In der Ukraine greift der Staat seit 2014 und 2022 stärker ein. In Kuba entscheidet der Staat durch zentrale Planung. Diese Tabelle ist ein KI-Inhalt.</a:t>
             </a:r>
             <a:endParaRPr lang="en-US" dirty="0"/>
           </a:p>
@@ -1176,7 +1183,8 @@
           <a:p>
             <a:r>
               <a:rPr lang="en-US" dirty="0"/>
-              <a:t/>
+              <a:t>Sprecher: Melanie
+Dritte Frage, Preisbildung: In Deutschland entstehen Preise am Markt, mit staatlichen Eingriffen in bestimmten Bereichen. In Marokko gibt es überwiegend Marktpreise, aber staatliche Einflussnahme zum Beispiel bei Energie und Grundnahrungsmitteln. In der Ukraine ebenfalls überwiegend Marktpreise, in Krisenzeiten aber Preisregulierungen. In Kuba werden Preise größtenteils staatlich festgelegt, das sind die Planpreise. Vierte Frage, Wettbewerb: Deutschland hat freien Wettbewerb, der Staat verhindert Monopole. In Marokko gibt es Wettbewerb, aber teils starke staatliche Einflussnahme und marktbeherrschende Staatsunternehmen. In der Ukraine ist Wettbewerb durch Krieg und staatliche Eingriffe teils eingeschränkt. In Kuba gibt es kaum Wettbewerb.</a:t>
             </a:r>
             <a:endParaRPr lang="en-US" dirty="0"/>
           </a:p>
@@ -1264,7 +1272,8 @@
           <a:p>
             <a:r>
               <a:rPr lang="en-US" dirty="0"/>
-              <a:t/>
+              <a:t>Sprecher: Melanie
+Fünfte Frage, Rolle des Staates: In Deutschland setzt der Staat den rechtlichen Rahmen und greift in bestimmten Bereichen ein, etwa in der Sozial-, Umwelt- und Wirtschaftspolitik. In Marokko spielt er eine starke lenkende Rolle, vor allem in strategischen Sektoren. In der Ukraine setzt er den Rahmen und greift in Krisenzeiten stärker ein, zum Beispiel bei Verteidigung und Wiederaufbau. In Kuba steuert er die Wirtschaft unmittelbar durch zentrale Planung und Weisungen. Sechste Frage, soziale Sicherung: Deutschland hat ein umfassendes Sozialsystem. Marokko hat staatliche Sozialprogramme, aber geringere Absicherung. Die Ukraine hat ein Sozialsystem, das durch den Krieg stark unter Druck steht. Kuba bietet grundlegende Absicherung, aber mit begrenzten Ressourcen.</a:t>
             </a:r>
             <a:endParaRPr lang="en-US" dirty="0"/>
           </a:p>
@@ -1352,7 +1361,8 @@
           <a:p>
             <a:r>
               <a:rPr lang="en-US" dirty="0"/>
-              <a:t/>
+              <a:t>Sprecher: Yasin
+Jetzt wird es praktisch. Stellt euch vor, ihr wollt ein Café eröffnen. Was bedeutet die Wirtschaftsordnung dann konkret? Vier Fragen: Wer darf gründen? Wer setzt die Preise? Welche Regeln gelten? Und woher kommen die Waren? Schon diese vier Fragen zeigen, wie stark die Ordnung eines Landes unsere Entscheidungen als Unternehmer beeinflusst.</a:t>
             </a:r>
             <a:endParaRPr lang="en-US" dirty="0"/>
           </a:p>
@@ -1440,7 +1450,8 @@
           <a:p>
             <a:r>
               <a:rPr lang="en-US" dirty="0"/>
-              <a:t/>
+              <a:t>Sprecher: Yasin
+Und so sieht das in den vier Ländern aus. In allen vier Ländern ist eine private Gründung möglich. In Deutschland gibt es freie unternehmerische Entscheidungen, aber klare Regeln zu Arbeit, Steuern und Hygiene. In Marokko können Finanzierung, Bürokratie und Formalisierung wichtige Hürden sein. In der Ukraine erhöhen Krieg, Energieversorgung und Wiederaufbau die wirtschaftlichen Risiken. In Kuba ist die private Gründung zunehmend möglich, die Reformen 2026 erweitern den Spielraum, aber staatliche Vorgaben und Versorgungsprobleme bleiben prägend. Auch das ist ein KI-Inhalt.</a:t>
             </a:r>
             <a:endParaRPr lang="en-US" dirty="0"/>
           </a:p>
@@ -1528,7 +1539,8 @@
           <a:p>
             <a:r>
               <a:rPr lang="en-US" dirty="0"/>
-              <a:t/>
+              <a:t>Sprecher: Anastasiia
+Das ist unser Plan. Erstens die Grundlagen: Was ist überhaupt eine Wirtschaftsordnung? Zweitens die Grundformen: Marktwirtschaft, Zentralverwaltungswirtschaft und die Soziale Marktwirtschaft. Drittens die Realität: Wie sieht es in Deutschland, Marokko, der Ukraine und Kuba aus? Viertens ein Praxischeck: Was bedeutet die Wirtschaftsordnung für ein Unternehmen? Fünftens gehen wir von der Theorie bis zur konkreten Café-Gründung. Und sechstens das Fazit: Markt, Staat – oder beides?</a:t>
             </a:r>
             <a:endParaRPr lang="en-US" dirty="0"/>
           </a:p>
@@ -1616,7 +1628,8 @@
           <a:p>
             <a:r>
               <a:rPr lang="en-US" dirty="0"/>
-              <a:t/>
+              <a:t>Sprecher: Yasin
+Zum Fazit: Markt und Staat sind kein Entweder-oder. Reale Volkswirtschaften sind Mischformen, und sie unterscheiden sich darin, wie stark Markt und Staat wirtschaftliche Entscheidungen beeinflussen. Staatliche Eingriffe bedeuten nicht automatisch Planwirtschaft, und mehr Privatwirtschaft bedeutet nicht automatisch freie Marktwirtschaft. Wirtschaftsordnungen verändern sich – besonders sichtbar an der Ukraine und an Kuba. Nicht das Etikett entscheidet, sondern die konkrete Mischung aus Markt, Staat und sozialer Absicherung.</a:t>
             </a:r>
             <a:endParaRPr lang="en-US" dirty="0"/>
           </a:p>
@@ -1704,7 +1717,8 @@
           <a:p>
             <a:r>
               <a:rPr lang="en-US" dirty="0"/>
-              <a:t/>
+              <a:t>Sprecher: alle
+Vielen Dank für eure Aufmerksamkeit! Wenn ihr noch Fragen, Kritik oder Feedback habt, freuen wir uns darauf. Das waren Anastasiia, Charlene, Melanie und Yasin.</a:t>
             </a:r>
             <a:endParaRPr lang="en-US" dirty="0"/>
           </a:p>
@@ -1792,7 +1806,8 @@
           <a:p>
             <a:r>
               <a:rPr lang="en-US" dirty="0"/>
-              <a:t/>
+              <a:t>Sprecher: -
+Das Glossar ist für Rückfragen gedacht und wird nicht vorgelesen. Bei Fragen zu einem Begriff, zum Beispiel Informeller Sektor oder Tarifautonomie, einfach hierher springen und die Definition vorlesen.</a:t>
             </a:r>
             <a:endParaRPr lang="en-US" dirty="0"/>
           </a:p>
@@ -1880,7 +1895,8 @@
           <a:p>
             <a:r>
               <a:rPr lang="en-US" dirty="0"/>
-              <a:t/>
+              <a:t>Sprecher: -
+Zu den Quellen: bpb für die Grundlagen, World Bank für Marokko, die EU-Kommission für die Ukraine, Reuters und AFP für Kuba. Drei Inhalte sind KI-generiert, nämlich die Bäckerei-Infografik, der Länder-Vergleich und die Café-Folie. Wir haben sie anhand der genannten Quellen geprüft.</a:t>
             </a:r>
             <a:endParaRPr lang="en-US" dirty="0"/>
           </a:p>
@@ -1968,7 +1984,8 @@
           <a:p>
             <a:r>
               <a:rPr lang="en-US" dirty="0"/>
-              <a:t/>
+              <a:t>Sprecher: Anastasiia
+Eine Wirtschaftsordnung legt die grundlegenden Regeln fest, nach denen eine Volkswirtschaft funktioniert. Fünf Fragen helfen uns dabei. Was wird produziert – Lebensmittel, Autos, Wohnungen? Wie wird produziert – entscheiden Unternehmen selbst oder wird zentral geplant? Wer trifft die Entscheidungen – Unternehmen, Verbraucher oder staatliche Stellen? Für wen wird produziert, also wie werden Güter verteilt – über Märkte und Kaufkraft oder durch staatliche Steuerung? Und: Wem gehören die Unternehmen und Produktionsmittel – Privaten oder dem Staat? Je nachdem, wie diese Fragen beantwortet werden, entstehen unterschiedliche Wirtschaftsordnungen.</a:t>
             </a:r>
             <a:endParaRPr lang="en-US" dirty="0"/>
           </a:p>
@@ -2056,7 +2073,8 @@
           <a:p>
             <a:r>
               <a:rPr lang="en-US" dirty="0"/>
-              <a:t/>
+              <a:t>Sprecher: Charlene
+Es gibt zwei Grundformen, die man Idealtypen nennt. Links die freie Marktwirtschaft: Unternehmen und Verbraucher entscheiden, das Eigentum ist überwiegend privat, die Preise entstehen durch Angebot und Nachfrage, geplant wird dezentral durch die Unternehmen, und der Wettbewerb ist das zentrale Steuerungselement. Rechts die Zentralverwaltungswirtschaft: Hier entscheiden zentrale staatliche Stellen, die Produktionsmittel sind überwiegend staatlich, Preise und Mengen können zentral festgelegt werden, die Planung läuft zentral, und der Wettbewerb ist stark eingeschränkt. Wichtig: Reale Wirtschaftsordnungen entsprechen diesen Modellen meist nicht vollständig.</a:t>
             </a:r>
             <a:endParaRPr lang="en-US" dirty="0"/>
           </a:p>
@@ -2144,7 +2162,8 @@
           <a:p>
             <a:r>
               <a:rPr lang="en-US" dirty="0"/>
-              <a:t/>
+              <a:t>Sprecher: Charlene
+Ein einfaches Beispiel: eine Bäckerei. In der Marktwirtschaft entscheidet die Bäckerei selbst: Welche Brote backen wir? Wie viele? Zu welchem Preis? Wo kaufen wir Zutaten? Wie reagieren wir auf Konkurrenz? Die Nachfrage der Kunden beeinflusst diese Entscheidungen. Bei zentraler Planung bestimmt dagegen eine zentrale Stelle die Produktionsmenge, die Ressourcenverteilung, das Sortiment, die Preise und die Verteilung. Nicht die einzelne Bäckerei, sondern die zentrale Planung koordiniert die wesentlichen Entscheidungen. Dieselbe wirtschaftliche Aufgabe, zwei unterschiedliche Wege der Steuerung. Das ist ein vereinfachtes Anschauungsbeispiel.</a:t>
             </a:r>
             <a:endParaRPr lang="en-US" dirty="0"/>
           </a:p>
@@ -2232,7 +2251,8 @@
           <a:p>
             <a:r>
               <a:rPr lang="en-US" dirty="0"/>
-              <a:t/>
+              <a:t>Sprecher: Charlene
+Beide Systeme haben Stärken und Schwächen. Die Marktwirtschaft bringt Wettbewerb, Innovation, große Auswahl, Eigeninitiative und eine flexible Reaktion auf die Nachfrage. Mögliche Probleme sind soziale Ungleichheit, die Marktmacht einzelner Unternehmen, Umweltbelastungen und externe Kosten – und gesellschaftlich wichtige Leistungen werden nicht automatisch ausreichend angeboten. Bei stärkerer Planung können Ressourcen gezielt gesteuert, die Versorgung politisch priorisiert, soziale Ziele direkt verfolgt und langfristig geplant werden. Die Probleme: ein sehr hoher Informationsbedarf, die Gefahr von Fehlplanung, weniger Wettbewerb, langsamere Anpassung und geringere Innovationsanreize.</a:t>
             </a:r>
             <a:endParaRPr lang="en-US" dirty="0"/>
           </a:p>
@@ -2320,7 +2340,8 @@
           <a:p>
             <a:r>
               <a:rPr lang="en-US" dirty="0"/>
-              <a:t/>
+              <a:t>Sprecher: Melanie
+Zwischen den beiden Extremen steht die Soziale Marktwirtschaft. Ihr Leitgedanke: Markt nutzen, Wettbewerb sichern, sozial absichern. Sie verbindet Wettbewerb, Privateigentum und Gewinnorientierung mit sozialem Ausgleich. Der Markt liefert Wettbewerb, Privateigentum, Unternehmensfreiheit, Angebot und Nachfrage und grundsätzlich freie Preisbildung. Der Staat setzt den Rechtsrahmen, schützt den Wettbewerb, sichert soziale Risiken ab, schützt Verbraucher und Beschäftigte und greift bei bestimmten Marktproblemen ein. Der soziale Ausgleich sind Sozialleistungen, die Absicherung von Lebensrisiken, Arbeitnehmerrechte, Teilhabe und Schutz.</a:t>
             </a:r>
             <a:endParaRPr lang="en-US" dirty="0"/>
           </a:p>
@@ -2408,7 +2429,8 @@
           <a:p>
             <a:r>
               <a:rPr lang="en-US" dirty="0"/>
-              <a:t/>
+              <a:t>Sprecher: Melanie
+Noch einmal die Bäckerei, diesmal in der Sozialen Marktwirtschaft. Die Bäckerei entscheidet selbst, im Rahmen der Marktregeln: Was verkaufe ich, zum Beispiel Brötchen, Brot oder Kuchen? Wie viel produziere ich, 50 oder 200 Brötchen? Welchen Preis verlange ich, etwa 0,50 Euro pro Brötchen? Aber sie muss Regeln einhalten: Arbeitsrecht mit Arbeitszeiten und Arbeitsschutz, Lebensmittelrecht mit Hygienevorschriften und Kennzeichnung, den Mindestlohn und das Steuerrecht. Der Staat entscheidet also nicht, wie viele Brötchen die Bäckerei morgen backen muss. Er bestimmt aber einen Teil der Spielregeln. Diese Folie ist ein KI-Inhalt, den wir geprüft haben.</a:t>
             </a:r>
             <a:endParaRPr lang="en-US" dirty="0"/>
           </a:p>
@@ -2496,7 +2518,8 @@
           <a:p>
             <a:r>
               <a:rPr lang="en-US" dirty="0"/>
-              <a:t/>
+              <a:t>Sprecher: Melanie
+Reale Volkswirtschaften sind Mischformen. Auf dem Messbalken seht ihr links mehr Markt, rechts mehr staatliche Lenkung. Deutschland liegt eher links, Marokko etwas weiter in der Mitte, die Ukraine noch etwas weiter Richtung Staat, und Kuba am weitesten rechts. Marktwirtschaftlich geprägte Länder haben Märkte, Wettbewerb und private Unternehmen, der Staat setzt den Rahmen. Stärker staatlich geprägte Systeme geben dem Staat eine größere Rolle, trotzdem können private Unternehmen und Marktmechanismen bestehen. Und: Wirtschaftsordnungen können sich verändern. Entscheidend ist nicht Markt ODER Staat, sondern wie beide miteinander verbunden sind.</a:t>
             </a:r>
             <a:endParaRPr lang="en-US" dirty="0"/>
           </a:p>

</xml_diff>